<commit_message>
fix: recentrer impact sur Point 4 (accès au financement)
- Remplacer "+45% revenu" par "90j premier crédit via FresCoop"
- Remplacer "Zones rurales USSD" par "Crédit sans garantie foncière"
- Impact social recentré: dossier portable, réduction risque SFD
- Régénérer le pitch deck PPTX avec les mêmes corrections

Co-Authored-By: Claude Opus 4.6 <noreply@anthropic.com>
</commit_message>
<xml_diff>
--- a/FRESCOOP_PITCH_DECK.pptx
+++ b/FRESCOOP_PITCH_DECK.pptx
@@ -7091,7 +7091,7 @@
               </a:defRPr>
             </a:pPr>
             <a:r>
-              <a:t>+45%</a:t>
+              <a:t>90j</a:t>
             </a:r>
           </a:p>
         </p:txBody>
@@ -7127,11 +7127,11 @@
               </a:defRPr>
             </a:pPr>
             <a:r>
-              <a:t>revenu additionnel</a:t>
+              <a:t>du premier crédit</a:t>
             </a:r>
             <a:br/>
             <a:r>
-              <a:t>pour l'agriculteur</a:t>
+              <a:t>obtenu via FresCoop</a:t>
             </a:r>
           </a:p>
         </p:txBody>
@@ -7265,7 +7265,7 @@
         <p:spPr>
           <a:xfrm>
             <a:off x="731520" y="3840480"/>
-            <a:ext cx="3657600" cy="365760"/>
+            <a:ext cx="5486400" cy="365760"/>
           </a:xfrm>
           <a:prstGeom prst="rect">
             <a:avLst/>
@@ -7287,7 +7287,7 @@
               </a:defRPr>
             </a:pPr>
             <a:r>
-              <a:t>IMPACT SOCIAL</a:t>
+              <a:t>IMPACT SUR L'ACCÈS AU FINANCEMENT</a:t>
             </a:r>
           </a:p>
         </p:txBody>
@@ -7403,7 +7403,7 @@
               </a:defRPr>
             </a:pPr>
             <a:r>
-              <a:t>40% des utilisateurs cibles sont des agricultrices — le scoring objectif élimine les biais de genre.</a:t>
+              <a:t>40% des agricultrices exclues accèdent enfin au crédit grâce à un scoring objectif sans biais de genre.</a:t>
             </a:r>
           </a:p>
         </p:txBody>
@@ -7483,7 +7483,7 @@
               </a:defRPr>
             </a:pPr>
             <a:r>
-              <a:t>Souveraineté des données</a:t>
+              <a:t>Dossier bancaire portable</a:t>
             </a:r>
           </a:p>
         </p:txBody>
@@ -7519,7 +7519,7 @@
               </a:defRPr>
             </a:pPr>
             <a:r>
-              <a:t>L'agriculteur décide qui voit son dossier. Portabilité totale. Conforme aux principes UEMOA.</a:t>
+              <a:t>L'agriculteur présente son score vérifié à n'importe quelle banque ou SFD de la zone UEMOA.</a:t>
             </a:r>
           </a:p>
         </p:txBody>
@@ -7599,7 +7599,7 @@
               </a:defRPr>
             </a:pPr>
             <a:r>
-              <a:t>Zones rurales — USSD</a:t>
+              <a:t>Crédit sans garantie foncière</a:t>
             </a:r>
           </a:p>
         </p:txBody>
@@ -7635,7 +7635,7 @@
               </a:defRPr>
             </a:pPr>
             <a:r>
-              <a:t>Accès complet via téléphone basique. Pas besoin de smartphone. Personne n'est exclu.</a:t>
+              <a:t>Le scoring remplace l'exigence de titre foncier — la preuve d'activité suffit pour le financement.</a:t>
             </a:r>
           </a:p>
         </p:txBody>
@@ -7715,7 +7715,7 @@
               </a:defRPr>
             </a:pPr>
             <a:r>
-              <a:t>Sécurité alimentaire</a:t>
+              <a:t>Réduction du risque SFD</a:t>
             </a:r>
           </a:p>
         </p:txBody>
@@ -7751,7 +7751,7 @@
               </a:defRPr>
             </a:pPr>
             <a:r>
-              <a:t>Plus d'agriculteurs financés = plus de production = impact direct sur la souveraineté alimentaire.</a:t>
+              <a:t>Les SFD financent en connaissance de cause : données vérifiées, historique complet, défaut prévisible.</a:t>
             </a:r>
           </a:p>
         </p:txBody>

</xml_diff>